<commit_message>
Spacing fixes on pptx
</commit_message>
<xml_diff>
--- a/docs/slides/final-presentation.pptx
+++ b/docs/slides/final-presentation.pptx
@@ -5,13 +5,13 @@
     <p:sldMasterId id="2147483648" r:id="rId1"/>
   </p:sldMasterIdLst>
   <p:sldIdLst>
-    <p:sldId id="256" r:id="rId7"/>
-    <p:sldId id="257" r:id="rId8"/>
-    <p:sldId id="258" r:id="rId9"/>
-    <p:sldId id="259" r:id="rId10"/>
-    <p:sldId id="260" r:id="rId11"/>
+    <p:sldId id="256" r:id="rId2"/>
+    <p:sldId id="257" r:id="rId3"/>
+    <p:sldId id="258" r:id="rId4"/>
+    <p:sldId id="259" r:id="rId5"/>
+    <p:sldId id="260" r:id="rId6"/>
   </p:sldIdLst>
-  <p:sldSz cx="12191695" cy="6858000" type="screen4x3"/>
+  <p:sldSz cx="12192000" cy="6858000"/>
   <p:notesSz cx="6858000" cy="9144000"/>
   <p:defaultTextStyle>
     <a:defPPr>
@@ -108,6 +108,22 @@
       </a:defRPr>
     </a:lvl9pPr>
   </p:defaultTextStyle>
+  <p:extLst>
+    <p:ext uri="{EFAFB233-063F-42B5-8137-9DF3F51BA10A}">
+      <p15:sldGuideLst xmlns:p15="http://schemas.microsoft.com/office/powerpoint/2012/main">
+        <p15:guide id="1" orient="horz" pos="2160">
+          <p15:clr>
+            <a:srgbClr val="A4A3A4"/>
+          </p15:clr>
+        </p15:guide>
+        <p15:guide id="2" pos="2880">
+          <p15:clr>
+            <a:srgbClr val="A4A3A4"/>
+          </p15:clr>
+        </p15:guide>
+      </p15:sldGuideLst>
+    </p:ext>
+  </p:extLst>
 </p:presentation>
 </file>
 
@@ -149,10 +165,9 @@
           <a:lstStyle/>
           <a:p>
             <a:r>
-              <a:rPr lang="en-US" smtClean="0"/>
+              <a:rPr lang="en-US"/>
               <a:t>Click to edit Master title style</a:t>
             </a:r>
-            <a:endParaRPr lang="en-US"/>
           </a:p>
         </p:txBody>
       </p:sp>
@@ -268,10 +283,9 @@
           </a:lstStyle>
           <a:p>
             <a:r>
-              <a:rPr lang="en-US" smtClean="0"/>
+              <a:rPr lang="en-US"/>
               <a:t>Click to edit Master subtitle style</a:t>
             </a:r>
-            <a:endParaRPr lang="en-US"/>
           </a:p>
         </p:txBody>
       </p:sp>
@@ -292,7 +306,7 @@
           <a:p>
             <a:fld id="{5BCAD085-E8A6-8845-BD4E-CB4CCA059FC4}" type="datetimeFigureOut">
               <a:rPr lang="en-US" smtClean="0"/>
-              <a:t>1/27/13</a:t>
+              <a:t>8/25/26</a:t>
             </a:fld>
             <a:endParaRPr lang="en-US"/>
           </a:p>
@@ -386,10 +400,9 @@
           <a:lstStyle/>
           <a:p>
             <a:r>
-              <a:rPr lang="en-US" smtClean="0"/>
+              <a:rPr lang="en-US"/>
               <a:t>Click to edit Master title style</a:t>
             </a:r>
-            <a:endParaRPr lang="en-US"/>
           </a:p>
         </p:txBody>
       </p:sp>
@@ -410,38 +423,37 @@
           <a:p>
             <a:pPr lvl="0"/>
             <a:r>
-              <a:rPr lang="en-US" smtClean="0"/>
+              <a:rPr lang="en-US"/>
               <a:t>Click to edit Master text styles</a:t>
             </a:r>
           </a:p>
           <a:p>
             <a:pPr lvl="1"/>
             <a:r>
-              <a:rPr lang="en-US" smtClean="0"/>
+              <a:rPr lang="en-US"/>
               <a:t>Second level</a:t>
             </a:r>
           </a:p>
           <a:p>
             <a:pPr lvl="2"/>
             <a:r>
-              <a:rPr lang="en-US" smtClean="0"/>
+              <a:rPr lang="en-US"/>
               <a:t>Third level</a:t>
             </a:r>
           </a:p>
           <a:p>
             <a:pPr lvl="3"/>
             <a:r>
-              <a:rPr lang="en-US" smtClean="0"/>
+              <a:rPr lang="en-US"/>
               <a:t>Fourth level</a:t>
             </a:r>
           </a:p>
           <a:p>
             <a:pPr lvl="4"/>
             <a:r>
-              <a:rPr lang="en-US" smtClean="0"/>
+              <a:rPr lang="en-US"/>
               <a:t>Fifth level</a:t>
             </a:r>
-            <a:endParaRPr lang="en-US"/>
           </a:p>
         </p:txBody>
       </p:sp>
@@ -462,7 +474,7 @@
           <a:p>
             <a:fld id="{5BCAD085-E8A6-8845-BD4E-CB4CCA059FC4}" type="datetimeFigureOut">
               <a:rPr lang="en-US" smtClean="0"/>
-              <a:t>1/27/13</a:t>
+              <a:t>8/25/26</a:t>
             </a:fld>
             <a:endParaRPr lang="en-US"/>
           </a:p>
@@ -561,10 +573,9 @@
           <a:lstStyle/>
           <a:p>
             <a:r>
-              <a:rPr lang="en-US" smtClean="0"/>
+              <a:rPr lang="en-US"/>
               <a:t>Click to edit Master title style</a:t>
             </a:r>
-            <a:endParaRPr lang="en-US"/>
           </a:p>
         </p:txBody>
       </p:sp>
@@ -590,38 +601,37 @@
           <a:p>
             <a:pPr lvl="0"/>
             <a:r>
-              <a:rPr lang="en-US" smtClean="0"/>
+              <a:rPr lang="en-US"/>
               <a:t>Click to edit Master text styles</a:t>
             </a:r>
           </a:p>
           <a:p>
             <a:pPr lvl="1"/>
             <a:r>
-              <a:rPr lang="en-US" smtClean="0"/>
+              <a:rPr lang="en-US"/>
               <a:t>Second level</a:t>
             </a:r>
           </a:p>
           <a:p>
             <a:pPr lvl="2"/>
             <a:r>
-              <a:rPr lang="en-US" smtClean="0"/>
+              <a:rPr lang="en-US"/>
               <a:t>Third level</a:t>
             </a:r>
           </a:p>
           <a:p>
             <a:pPr lvl="3"/>
             <a:r>
-              <a:rPr lang="en-US" smtClean="0"/>
+              <a:rPr lang="en-US"/>
               <a:t>Fourth level</a:t>
             </a:r>
           </a:p>
           <a:p>
             <a:pPr lvl="4"/>
             <a:r>
-              <a:rPr lang="en-US" smtClean="0"/>
+              <a:rPr lang="en-US"/>
               <a:t>Fifth level</a:t>
             </a:r>
-            <a:endParaRPr lang="en-US"/>
           </a:p>
         </p:txBody>
       </p:sp>
@@ -642,7 +652,7 @@
           <a:p>
             <a:fld id="{5BCAD085-E8A6-8845-BD4E-CB4CCA059FC4}" type="datetimeFigureOut">
               <a:rPr lang="en-US" smtClean="0"/>
-              <a:t>1/27/13</a:t>
+              <a:t>8/25/26</a:t>
             </a:fld>
             <a:endParaRPr lang="en-US"/>
           </a:p>
@@ -736,10 +746,9 @@
           <a:lstStyle/>
           <a:p>
             <a:r>
-              <a:rPr lang="en-US" smtClean="0"/>
+              <a:rPr lang="en-US"/>
               <a:t>Click to edit Master title style</a:t>
             </a:r>
-            <a:endParaRPr lang="en-US"/>
           </a:p>
         </p:txBody>
       </p:sp>
@@ -760,38 +769,37 @@
           <a:p>
             <a:pPr lvl="0"/>
             <a:r>
-              <a:rPr lang="en-US" smtClean="0"/>
+              <a:rPr lang="en-US"/>
               <a:t>Click to edit Master text styles</a:t>
             </a:r>
           </a:p>
           <a:p>
             <a:pPr lvl="1"/>
             <a:r>
-              <a:rPr lang="en-US" smtClean="0"/>
+              <a:rPr lang="en-US"/>
               <a:t>Second level</a:t>
             </a:r>
           </a:p>
           <a:p>
             <a:pPr lvl="2"/>
             <a:r>
-              <a:rPr lang="en-US" smtClean="0"/>
+              <a:rPr lang="en-US"/>
               <a:t>Third level</a:t>
             </a:r>
           </a:p>
           <a:p>
             <a:pPr lvl="3"/>
             <a:r>
-              <a:rPr lang="en-US" smtClean="0"/>
+              <a:rPr lang="en-US"/>
               <a:t>Fourth level</a:t>
             </a:r>
           </a:p>
           <a:p>
             <a:pPr lvl="4"/>
             <a:r>
-              <a:rPr lang="en-US" smtClean="0"/>
+              <a:rPr lang="en-US"/>
               <a:t>Fifth level</a:t>
             </a:r>
-            <a:endParaRPr lang="en-US"/>
           </a:p>
         </p:txBody>
       </p:sp>
@@ -812,7 +820,7 @@
           <a:p>
             <a:fld id="{5BCAD085-E8A6-8845-BD4E-CB4CCA059FC4}" type="datetimeFigureOut">
               <a:rPr lang="en-US" smtClean="0"/>
-              <a:t>1/27/13</a:t>
+              <a:t>8/25/26</a:t>
             </a:fld>
             <a:endParaRPr lang="en-US"/>
           </a:p>
@@ -915,10 +923,9 @@
           </a:lstStyle>
           <a:p>
             <a:r>
-              <a:rPr lang="en-US" smtClean="0"/>
+              <a:rPr lang="en-US"/>
               <a:t>Click to edit Master title style</a:t>
             </a:r>
-            <a:endParaRPr lang="en-US"/>
           </a:p>
         </p:txBody>
       </p:sp>
@@ -1035,7 +1042,7 @@
           <a:p>
             <a:pPr lvl="0"/>
             <a:r>
-              <a:rPr lang="en-US" smtClean="0"/>
+              <a:rPr lang="en-US"/>
               <a:t>Click to edit Master text styles</a:t>
             </a:r>
           </a:p>
@@ -1058,7 +1065,7 @@
           <a:p>
             <a:fld id="{5BCAD085-E8A6-8845-BD4E-CB4CCA059FC4}" type="datetimeFigureOut">
               <a:rPr lang="en-US" smtClean="0"/>
-              <a:t>1/27/13</a:t>
+              <a:t>8/25/26</a:t>
             </a:fld>
             <a:endParaRPr lang="en-US"/>
           </a:p>
@@ -1152,10 +1159,9 @@
           <a:lstStyle/>
           <a:p>
             <a:r>
-              <a:rPr lang="en-US" smtClean="0"/>
+              <a:rPr lang="en-US"/>
               <a:t>Click to edit Master title style</a:t>
             </a:r>
-            <a:endParaRPr lang="en-US"/>
           </a:p>
         </p:txBody>
       </p:sp>
@@ -1209,38 +1215,37 @@
           <a:p>
             <a:pPr lvl="0"/>
             <a:r>
-              <a:rPr lang="en-US" smtClean="0"/>
+              <a:rPr lang="en-US"/>
               <a:t>Click to edit Master text styles</a:t>
             </a:r>
           </a:p>
           <a:p>
             <a:pPr lvl="1"/>
             <a:r>
-              <a:rPr lang="en-US" smtClean="0"/>
+              <a:rPr lang="en-US"/>
               <a:t>Second level</a:t>
             </a:r>
           </a:p>
           <a:p>
             <a:pPr lvl="2"/>
             <a:r>
-              <a:rPr lang="en-US" smtClean="0"/>
+              <a:rPr lang="en-US"/>
               <a:t>Third level</a:t>
             </a:r>
           </a:p>
           <a:p>
             <a:pPr lvl="3"/>
             <a:r>
-              <a:rPr lang="en-US" smtClean="0"/>
+              <a:rPr lang="en-US"/>
               <a:t>Fourth level</a:t>
             </a:r>
           </a:p>
           <a:p>
             <a:pPr lvl="4"/>
             <a:r>
-              <a:rPr lang="en-US" smtClean="0"/>
+              <a:rPr lang="en-US"/>
               <a:t>Fifth level</a:t>
             </a:r>
-            <a:endParaRPr lang="en-US"/>
           </a:p>
         </p:txBody>
       </p:sp>
@@ -1294,38 +1299,37 @@
           <a:p>
             <a:pPr lvl="0"/>
             <a:r>
-              <a:rPr lang="en-US" smtClean="0"/>
+              <a:rPr lang="en-US"/>
               <a:t>Click to edit Master text styles</a:t>
             </a:r>
           </a:p>
           <a:p>
             <a:pPr lvl="1"/>
             <a:r>
-              <a:rPr lang="en-US" smtClean="0"/>
+              <a:rPr lang="en-US"/>
               <a:t>Second level</a:t>
             </a:r>
           </a:p>
           <a:p>
             <a:pPr lvl="2"/>
             <a:r>
-              <a:rPr lang="en-US" smtClean="0"/>
+              <a:rPr lang="en-US"/>
               <a:t>Third level</a:t>
             </a:r>
           </a:p>
           <a:p>
             <a:pPr lvl="3"/>
             <a:r>
-              <a:rPr lang="en-US" smtClean="0"/>
+              <a:rPr lang="en-US"/>
               <a:t>Fourth level</a:t>
             </a:r>
           </a:p>
           <a:p>
             <a:pPr lvl="4"/>
             <a:r>
-              <a:rPr lang="en-US" smtClean="0"/>
+              <a:rPr lang="en-US"/>
               <a:t>Fifth level</a:t>
             </a:r>
-            <a:endParaRPr lang="en-US"/>
           </a:p>
         </p:txBody>
       </p:sp>
@@ -1346,7 +1350,7 @@
           <a:p>
             <a:fld id="{5BCAD085-E8A6-8845-BD4E-CB4CCA059FC4}" type="datetimeFigureOut">
               <a:rPr lang="en-US" smtClean="0"/>
-              <a:t>1/27/13</a:t>
+              <a:t>8/25/26</a:t>
             </a:fld>
             <a:endParaRPr lang="en-US"/>
           </a:p>
@@ -1444,10 +1448,9 @@
           </a:lstStyle>
           <a:p>
             <a:r>
-              <a:rPr lang="en-US" smtClean="0"/>
+              <a:rPr lang="en-US"/>
               <a:t>Click to edit Master title style</a:t>
             </a:r>
-            <a:endParaRPr lang="en-US"/>
           </a:p>
         </p:txBody>
       </p:sp>
@@ -1510,7 +1513,7 @@
           <a:p>
             <a:pPr lvl="0"/>
             <a:r>
-              <a:rPr lang="en-US" smtClean="0"/>
+              <a:rPr lang="en-US"/>
               <a:t>Click to edit Master text styles</a:t>
             </a:r>
           </a:p>
@@ -1566,38 +1569,37 @@
           <a:p>
             <a:pPr lvl="0"/>
             <a:r>
-              <a:rPr lang="en-US" smtClean="0"/>
+              <a:rPr lang="en-US"/>
               <a:t>Click to edit Master text styles</a:t>
             </a:r>
           </a:p>
           <a:p>
             <a:pPr lvl="1"/>
             <a:r>
-              <a:rPr lang="en-US" smtClean="0"/>
+              <a:rPr lang="en-US"/>
               <a:t>Second level</a:t>
             </a:r>
           </a:p>
           <a:p>
             <a:pPr lvl="2"/>
             <a:r>
-              <a:rPr lang="en-US" smtClean="0"/>
+              <a:rPr lang="en-US"/>
               <a:t>Third level</a:t>
             </a:r>
           </a:p>
           <a:p>
             <a:pPr lvl="3"/>
             <a:r>
-              <a:rPr lang="en-US" smtClean="0"/>
+              <a:rPr lang="en-US"/>
               <a:t>Fourth level</a:t>
             </a:r>
           </a:p>
           <a:p>
             <a:pPr lvl="4"/>
             <a:r>
-              <a:rPr lang="en-US" smtClean="0"/>
+              <a:rPr lang="en-US"/>
               <a:t>Fifth level</a:t>
             </a:r>
-            <a:endParaRPr lang="en-US"/>
           </a:p>
         </p:txBody>
       </p:sp>
@@ -1660,7 +1662,7 @@
           <a:p>
             <a:pPr lvl="0"/>
             <a:r>
-              <a:rPr lang="en-US" smtClean="0"/>
+              <a:rPr lang="en-US"/>
               <a:t>Click to edit Master text styles</a:t>
             </a:r>
           </a:p>
@@ -1716,38 +1718,37 @@
           <a:p>
             <a:pPr lvl="0"/>
             <a:r>
-              <a:rPr lang="en-US" smtClean="0"/>
+              <a:rPr lang="en-US"/>
               <a:t>Click to edit Master text styles</a:t>
             </a:r>
           </a:p>
           <a:p>
             <a:pPr lvl="1"/>
             <a:r>
-              <a:rPr lang="en-US" smtClean="0"/>
+              <a:rPr lang="en-US"/>
               <a:t>Second level</a:t>
             </a:r>
           </a:p>
           <a:p>
             <a:pPr lvl="2"/>
             <a:r>
-              <a:rPr lang="en-US" smtClean="0"/>
+              <a:rPr lang="en-US"/>
               <a:t>Third level</a:t>
             </a:r>
           </a:p>
           <a:p>
             <a:pPr lvl="3"/>
             <a:r>
-              <a:rPr lang="en-US" smtClean="0"/>
+              <a:rPr lang="en-US"/>
               <a:t>Fourth level</a:t>
             </a:r>
           </a:p>
           <a:p>
             <a:pPr lvl="4"/>
             <a:r>
-              <a:rPr lang="en-US" smtClean="0"/>
+              <a:rPr lang="en-US"/>
               <a:t>Fifth level</a:t>
             </a:r>
-            <a:endParaRPr lang="en-US"/>
           </a:p>
         </p:txBody>
       </p:sp>
@@ -1768,7 +1769,7 @@
           <a:p>
             <a:fld id="{5BCAD085-E8A6-8845-BD4E-CB4CCA059FC4}" type="datetimeFigureOut">
               <a:rPr lang="en-US" smtClean="0"/>
-              <a:t>1/27/13</a:t>
+              <a:t>8/25/26</a:t>
             </a:fld>
             <a:endParaRPr lang="en-US"/>
           </a:p>
@@ -1862,10 +1863,9 @@
           <a:lstStyle/>
           <a:p>
             <a:r>
-              <a:rPr lang="en-US" smtClean="0"/>
+              <a:rPr lang="en-US"/>
               <a:t>Click to edit Master title style</a:t>
             </a:r>
-            <a:endParaRPr lang="en-US"/>
           </a:p>
         </p:txBody>
       </p:sp>
@@ -1886,7 +1886,7 @@
           <a:p>
             <a:fld id="{5BCAD085-E8A6-8845-BD4E-CB4CCA059FC4}" type="datetimeFigureOut">
               <a:rPr lang="en-US" smtClean="0"/>
-              <a:t>1/27/13</a:t>
+              <a:t>8/25/26</a:t>
             </a:fld>
             <a:endParaRPr lang="en-US"/>
           </a:p>
@@ -1981,7 +1981,7 @@
           <a:p>
             <a:fld id="{5BCAD085-E8A6-8845-BD4E-CB4CCA059FC4}" type="datetimeFigureOut">
               <a:rPr lang="en-US" smtClean="0"/>
-              <a:t>1/27/13</a:t>
+              <a:t>8/25/26</a:t>
             </a:fld>
             <a:endParaRPr lang="en-US"/>
           </a:p>
@@ -2084,10 +2084,9 @@
           </a:lstStyle>
           <a:p>
             <a:r>
-              <a:rPr lang="en-US" smtClean="0"/>
+              <a:rPr lang="en-US"/>
               <a:t>Click to edit Master title style</a:t>
             </a:r>
-            <a:endParaRPr lang="en-US"/>
           </a:p>
         </p:txBody>
       </p:sp>
@@ -2141,38 +2140,37 @@
           <a:p>
             <a:pPr lvl="0"/>
             <a:r>
-              <a:rPr lang="en-US" smtClean="0"/>
+              <a:rPr lang="en-US"/>
               <a:t>Click to edit Master text styles</a:t>
             </a:r>
           </a:p>
           <a:p>
             <a:pPr lvl="1"/>
             <a:r>
-              <a:rPr lang="en-US" smtClean="0"/>
+              <a:rPr lang="en-US"/>
               <a:t>Second level</a:t>
             </a:r>
           </a:p>
           <a:p>
             <a:pPr lvl="2"/>
             <a:r>
-              <a:rPr lang="en-US" smtClean="0"/>
+              <a:rPr lang="en-US"/>
               <a:t>Third level</a:t>
             </a:r>
           </a:p>
           <a:p>
             <a:pPr lvl="3"/>
             <a:r>
-              <a:rPr lang="en-US" smtClean="0"/>
+              <a:rPr lang="en-US"/>
               <a:t>Fourth level</a:t>
             </a:r>
           </a:p>
           <a:p>
             <a:pPr lvl="4"/>
             <a:r>
-              <a:rPr lang="en-US" smtClean="0"/>
+              <a:rPr lang="en-US"/>
               <a:t>Fifth level</a:t>
             </a:r>
-            <a:endParaRPr lang="en-US"/>
           </a:p>
         </p:txBody>
       </p:sp>
@@ -2235,7 +2233,7 @@
           <a:p>
             <a:pPr lvl="0"/>
             <a:r>
-              <a:rPr lang="en-US" smtClean="0"/>
+              <a:rPr lang="en-US"/>
               <a:t>Click to edit Master text styles</a:t>
             </a:r>
           </a:p>
@@ -2258,7 +2256,7 @@
           <a:p>
             <a:fld id="{5BCAD085-E8A6-8845-BD4E-CB4CCA059FC4}" type="datetimeFigureOut">
               <a:rPr lang="en-US" smtClean="0"/>
-              <a:t>1/27/13</a:t>
+              <a:t>8/25/26</a:t>
             </a:fld>
             <a:endParaRPr lang="en-US"/>
           </a:p>
@@ -2361,10 +2359,9 @@
           </a:lstStyle>
           <a:p>
             <a:r>
-              <a:rPr lang="en-US" smtClean="0"/>
+              <a:rPr lang="en-US"/>
               <a:t>Click to edit Master title style</a:t>
             </a:r>
-            <a:endParaRPr lang="en-US"/>
           </a:p>
         </p:txBody>
       </p:sp>
@@ -2488,7 +2485,7 @@
           <a:p>
             <a:pPr lvl="0"/>
             <a:r>
-              <a:rPr lang="en-US" smtClean="0"/>
+              <a:rPr lang="en-US"/>
               <a:t>Click to edit Master text styles</a:t>
             </a:r>
           </a:p>
@@ -2511,7 +2508,7 @@
           <a:p>
             <a:fld id="{5BCAD085-E8A6-8845-BD4E-CB4CCA059FC4}" type="datetimeFigureOut">
               <a:rPr lang="en-US" smtClean="0"/>
-              <a:t>1/27/13</a:t>
+              <a:t>8/25/26</a:t>
             </a:fld>
             <a:endParaRPr lang="en-US"/>
           </a:p>
@@ -2620,10 +2617,9 @@
           <a:lstStyle/>
           <a:p>
             <a:r>
-              <a:rPr lang="en-US" smtClean="0"/>
+              <a:rPr lang="en-US"/>
               <a:t>Click to edit Master title style</a:t>
             </a:r>
-            <a:endParaRPr lang="en-US"/>
           </a:p>
         </p:txBody>
       </p:sp>
@@ -2654,38 +2650,37 @@
           <a:p>
             <a:pPr lvl="0"/>
             <a:r>
-              <a:rPr lang="en-US" smtClean="0"/>
+              <a:rPr lang="en-US"/>
               <a:t>Click to edit Master text styles</a:t>
             </a:r>
           </a:p>
           <a:p>
             <a:pPr lvl="1"/>
             <a:r>
-              <a:rPr lang="en-US" smtClean="0"/>
+              <a:rPr lang="en-US"/>
               <a:t>Second level</a:t>
             </a:r>
           </a:p>
           <a:p>
             <a:pPr lvl="2"/>
             <a:r>
-              <a:rPr lang="en-US" smtClean="0"/>
+              <a:rPr lang="en-US"/>
               <a:t>Third level</a:t>
             </a:r>
           </a:p>
           <a:p>
             <a:pPr lvl="3"/>
             <a:r>
-              <a:rPr lang="en-US" smtClean="0"/>
+              <a:rPr lang="en-US"/>
               <a:t>Fourth level</a:t>
             </a:r>
           </a:p>
           <a:p>
             <a:pPr lvl="4"/>
             <a:r>
-              <a:rPr lang="en-US" smtClean="0"/>
+              <a:rPr lang="en-US"/>
               <a:t>Fifth level</a:t>
             </a:r>
-            <a:endParaRPr lang="en-US"/>
           </a:p>
         </p:txBody>
       </p:sp>
@@ -2724,7 +2719,7 @@
           <a:p>
             <a:fld id="{5BCAD085-E8A6-8845-BD4E-CB4CCA059FC4}" type="datetimeFigureOut">
               <a:rPr lang="en-US" smtClean="0"/>
-              <a:t>1/27/13</a:t>
+              <a:t>8/25/26</a:t>
             </a:fld>
             <a:endParaRPr lang="en-US"/>
           </a:p>
@@ -3083,7 +3078,7 @@
 </file>
 
 <file path=ppt/slides/slide1.xml><?xml version="1.0" encoding="utf-8"?>
-<p:sld xmlns:a="http://schemas.openxmlformats.org/drawingml/2006/main" xmlns:p="http://schemas.openxmlformats.org/presentationml/2006/main" xmlns:r="http://schemas.openxmlformats.org/officeDocument/2006/relationships">
+<p:sld xmlns:a="http://schemas.openxmlformats.org/drawingml/2006/main" xmlns:r="http://schemas.openxmlformats.org/officeDocument/2006/relationships" xmlns:p="http://schemas.openxmlformats.org/presentationml/2006/main">
   <p:cSld>
     <p:spTree>
       <p:nvGrpSpPr>
@@ -3091,7 +3086,14 @@
         <p:cNvGrpSpPr/>
         <p:nvPr/>
       </p:nvGrpSpPr>
-      <p:grpSpPr/>
+      <p:grpSpPr>
+        <a:xfrm>
+          <a:off x="0" y="0"/>
+          <a:ext cx="0" cy="0"/>
+          <a:chOff x="0" y="0"/>
+          <a:chExt cx="0" cy="0"/>
+        </a:xfrm>
+      </p:grpSpPr>
       <p:sp>
         <p:nvSpPr>
           <p:cNvPr id="2" name="Rectangle 1"/>
@@ -3132,6 +3134,7 @@
           <a:lstStyle/>
           <a:p>
             <a:pPr algn="ctr"/>
+            <a:endParaRPr/>
           </a:p>
         </p:txBody>
       </p:sp>
@@ -3242,7 +3245,7 @@
         </p:nvSpPr>
         <p:spPr>
           <a:xfrm>
-            <a:off x="548640" y="1661350"/>
+            <a:off x="548640" y="2018843"/>
             <a:ext cx="5394960" cy="274320"/>
           </a:xfrm>
           <a:prstGeom prst="rect">
@@ -3275,7 +3278,7 @@
         </p:nvSpPr>
         <p:spPr>
           <a:xfrm>
-            <a:off x="548640" y="1986533"/>
+            <a:off x="548640" y="2694011"/>
             <a:ext cx="5394960" cy="274320"/>
           </a:xfrm>
           <a:prstGeom prst="rect">
@@ -3308,7 +3311,7 @@
         </p:nvSpPr>
         <p:spPr>
           <a:xfrm>
-            <a:off x="548640" y="2271140"/>
+            <a:off x="548640" y="3125422"/>
             <a:ext cx="5394960" cy="274320"/>
           </a:xfrm>
           <a:prstGeom prst="rect">
@@ -3339,11 +3342,17 @@
           <p:cNvGraphicFramePr>
             <a:graphicFrameLocks noGrp="1"/>
           </p:cNvGraphicFramePr>
-          <p:nvPr/>
+          <p:nvPr>
+            <p:extLst>
+              <p:ext uri="{D42A27DB-BD31-4B8C-83A1-F6EECF244321}">
+                <p14:modId xmlns:p14="http://schemas.microsoft.com/office/powerpoint/2010/main" val="1629435378"/>
+              </p:ext>
+            </p:extLst>
+          </p:nvPr>
         </p:nvGraphicFramePr>
         <p:xfrm>
-          <a:off x="548640" y="2578035"/>
-          <a:ext cx="5394960" cy="950976"/>
+          <a:off x="548640" y="3613023"/>
+          <a:ext cx="5394960" cy="1386840"/>
         </p:xfrm>
         <a:graphic>
           <a:graphicData uri="http://schemas.openxmlformats.org/drawingml/2006/table">
@@ -3352,9 +3361,27 @@
                 <a:tableStyleId>{5C22544A-7EE6-4342-B048-85BDC9FD1C3A}</a:tableStyleId>
               </a:tblPr>
               <a:tblGrid>
-                <a:gridCol w="1798320"/>
-                <a:gridCol w="1798320"/>
-                <a:gridCol w="1798320"/>
+                <a:gridCol w="1798320">
+                  <a:extLst>
+                    <a:ext uri="{9D8B030D-6E8A-4147-A177-3AD203B41FA5}">
+                      <a16:colId xmlns:a16="http://schemas.microsoft.com/office/drawing/2014/main" val="20000"/>
+                    </a:ext>
+                  </a:extLst>
+                </a:gridCol>
+                <a:gridCol w="1798320">
+                  <a:extLst>
+                    <a:ext uri="{9D8B030D-6E8A-4147-A177-3AD203B41FA5}">
+                      <a16:colId xmlns:a16="http://schemas.microsoft.com/office/drawing/2014/main" val="20001"/>
+                    </a:ext>
+                  </a:extLst>
+                </a:gridCol>
+                <a:gridCol w="1798320">
+                  <a:extLst>
+                    <a:ext uri="{9D8B030D-6E8A-4147-A177-3AD203B41FA5}">
+                      <a16:colId xmlns:a16="http://schemas.microsoft.com/office/drawing/2014/main" val="20002"/>
+                    </a:ext>
+                  </a:extLst>
+                </a:gridCol>
               </a:tblGrid>
               <a:tr h="237744">
                 <a:tc>
@@ -3426,6 +3453,11 @@
                     </a:solidFill>
                   </a:tcPr>
                 </a:tc>
+                <a:extLst>
+                  <a:ext uri="{0D108BD9-81ED-4DB2-BD59-A6C34878D82A}">
+                    <a16:rowId xmlns:a16="http://schemas.microsoft.com/office/drawing/2014/main" val="10000"/>
+                  </a:ext>
+                </a:extLst>
               </a:tr>
               <a:tr h="237744">
                 <a:tc>
@@ -3497,6 +3529,11 @@
                     </a:solidFill>
                   </a:tcPr>
                 </a:tc>
+                <a:extLst>
+                  <a:ext uri="{0D108BD9-81ED-4DB2-BD59-A6C34878D82A}">
+                    <a16:rowId xmlns:a16="http://schemas.microsoft.com/office/drawing/2014/main" val="10001"/>
+                  </a:ext>
+                </a:extLst>
               </a:tr>
               <a:tr h="237744">
                 <a:tc>
@@ -3568,6 +3605,11 @@
                     </a:solidFill>
                   </a:tcPr>
                 </a:tc>
+                <a:extLst>
+                  <a:ext uri="{0D108BD9-81ED-4DB2-BD59-A6C34878D82A}">
+                    <a16:rowId xmlns:a16="http://schemas.microsoft.com/office/drawing/2014/main" val="10002"/>
+                  </a:ext>
+                </a:extLst>
               </a:tr>
               <a:tr h="237744">
                 <a:tc>
@@ -3639,6 +3681,11 @@
                     </a:solidFill>
                   </a:tcPr>
                 </a:tc>
+                <a:extLst>
+                  <a:ext uri="{0D108BD9-81ED-4DB2-BD59-A6C34878D82A}">
+                    <a16:rowId xmlns:a16="http://schemas.microsoft.com/office/drawing/2014/main" val="10003"/>
+                  </a:ext>
+                </a:extLst>
               </a:tr>
             </a:tbl>
           </a:graphicData>
@@ -3652,7 +3699,7 @@
         </p:nvSpPr>
         <p:spPr>
           <a:xfrm>
-            <a:off x="548640" y="3711891"/>
+            <a:off x="6502873" y="1106424"/>
             <a:ext cx="5394960" cy="274320"/>
           </a:xfrm>
           <a:prstGeom prst="rect">
@@ -3685,8 +3732,8 @@
         </p:nvSpPr>
         <p:spPr>
           <a:xfrm>
-            <a:off x="548640" y="3996498"/>
-            <a:ext cx="5394960" cy="274320"/>
+            <a:off x="6502873" y="1466699"/>
+            <a:ext cx="5394960" cy="1508105"/>
           </a:xfrm>
           <a:prstGeom prst="rect">
             <a:avLst/>
@@ -3705,7 +3752,152 @@
                   <a:srgbClr val="1E1B4B"/>
                 </a:solidFill>
               </a:rPr>
-              <a:t>Load balancing · health checking · auto-scaling simulation · stateless application tier · CDN-offloaded assets · role-based access control · containerization · CI/CD</a:t>
+              <a:t>Load balancing </a:t>
+            </a:r>
+            <a:endParaRPr lang="en-US" sz="1150">
+              <a:solidFill>
+                <a:srgbClr val="1E1B4B"/>
+              </a:solidFill>
+            </a:endParaRPr>
+          </a:p>
+          <a:p>
+            <a:r>
+              <a:rPr lang="en-US" sz="1150" b="0">
+                <a:solidFill>
+                  <a:srgbClr val="1E1B4B"/>
+                </a:solidFill>
+              </a:rPr>
+              <a:t>H</a:t>
+            </a:r>
+            <a:r>
+              <a:rPr sz="1150" b="0">
+                <a:solidFill>
+                  <a:srgbClr val="1E1B4B"/>
+                </a:solidFill>
+              </a:rPr>
+              <a:t>ealth checking </a:t>
+            </a:r>
+            <a:endParaRPr lang="en-US" sz="1150">
+              <a:solidFill>
+                <a:srgbClr val="1E1B4B"/>
+              </a:solidFill>
+            </a:endParaRPr>
+          </a:p>
+          <a:p>
+            <a:r>
+              <a:rPr lang="en-US" sz="1150" b="0">
+                <a:solidFill>
+                  <a:srgbClr val="1E1B4B"/>
+                </a:solidFill>
+              </a:rPr>
+              <a:t>A</a:t>
+            </a:r>
+            <a:r>
+              <a:rPr sz="1150" b="0">
+                <a:solidFill>
+                  <a:srgbClr val="1E1B4B"/>
+                </a:solidFill>
+              </a:rPr>
+              <a:t>uto-scaling simulation </a:t>
+            </a:r>
+            <a:endParaRPr lang="en-US" sz="1150" b="0">
+              <a:solidFill>
+                <a:srgbClr val="1E1B4B"/>
+              </a:solidFill>
+            </a:endParaRPr>
+          </a:p>
+          <a:p>
+            <a:r>
+              <a:rPr lang="en-US" sz="1150">
+                <a:solidFill>
+                  <a:srgbClr val="1E1B4B"/>
+                </a:solidFill>
+              </a:rPr>
+              <a:t>S</a:t>
+            </a:r>
+            <a:r>
+              <a:rPr sz="1150" b="0">
+                <a:solidFill>
+                  <a:srgbClr val="1E1B4B"/>
+                </a:solidFill>
+              </a:rPr>
+              <a:t>tateless application tier </a:t>
+            </a:r>
+            <a:endParaRPr lang="en-US" sz="1150" b="0">
+              <a:solidFill>
+                <a:srgbClr val="1E1B4B"/>
+              </a:solidFill>
+            </a:endParaRPr>
+          </a:p>
+          <a:p>
+            <a:r>
+              <a:rPr sz="1150" b="0">
+                <a:solidFill>
+                  <a:srgbClr val="1E1B4B"/>
+                </a:solidFill>
+              </a:rPr>
+              <a:t>CDN-offloaded assets </a:t>
+            </a:r>
+            <a:endParaRPr lang="en-US" sz="1150" b="0">
+              <a:solidFill>
+                <a:srgbClr val="1E1B4B"/>
+              </a:solidFill>
+            </a:endParaRPr>
+          </a:p>
+          <a:p>
+            <a:r>
+              <a:rPr lang="en-US" sz="1150" b="0">
+                <a:solidFill>
+                  <a:srgbClr val="1E1B4B"/>
+                </a:solidFill>
+              </a:rPr>
+              <a:t>R</a:t>
+            </a:r>
+            <a:r>
+              <a:rPr sz="1150" b="0">
+                <a:solidFill>
+                  <a:srgbClr val="1E1B4B"/>
+                </a:solidFill>
+              </a:rPr>
+              <a:t>ole-based access control </a:t>
+            </a:r>
+            <a:endParaRPr lang="en-US" sz="1150" b="0">
+              <a:solidFill>
+                <a:srgbClr val="1E1B4B"/>
+              </a:solidFill>
+            </a:endParaRPr>
+          </a:p>
+          <a:p>
+            <a:r>
+              <a:rPr lang="en-US" sz="1150" b="0">
+                <a:solidFill>
+                  <a:srgbClr val="1E1B4B"/>
+                </a:solidFill>
+              </a:rPr>
+              <a:t>C</a:t>
+            </a:r>
+            <a:r>
+              <a:rPr sz="1150" b="0">
+                <a:solidFill>
+                  <a:srgbClr val="1E1B4B"/>
+                </a:solidFill>
+              </a:rPr>
+              <a:t>ontainerization </a:t>
+            </a:r>
+            <a:endParaRPr lang="en-US" sz="1150" b="0">
+              <a:solidFill>
+                <a:srgbClr val="1E1B4B"/>
+              </a:solidFill>
+            </a:endParaRPr>
+          </a:p>
+          <a:p>
+            <a:r>
+              <a:rPr sz="1150" b="0">
+                <a:solidFill>
+                  <a:srgbClr val="1E1B4B"/>
+                </a:solidFill>
+              </a:rPr>
+              <a:t>CI/CD</a:t>
             </a:r>
           </a:p>
         </p:txBody>
@@ -3718,7 +3910,7 @@
         </p:nvSpPr>
         <p:spPr>
           <a:xfrm>
-            <a:off x="548640" y="4266817"/>
+            <a:off x="6502873" y="3060759"/>
             <a:ext cx="5394960" cy="274320"/>
           </a:xfrm>
           <a:prstGeom prst="rect">
@@ -3818,7 +4010,7 @@
 </file>
 
 <file path=ppt/slides/slide2.xml><?xml version="1.0" encoding="utf-8"?>
-<p:sld xmlns:a="http://schemas.openxmlformats.org/drawingml/2006/main" xmlns:p="http://schemas.openxmlformats.org/presentationml/2006/main" xmlns:r="http://schemas.openxmlformats.org/officeDocument/2006/relationships">
+<p:sld xmlns:a="http://schemas.openxmlformats.org/drawingml/2006/main" xmlns:r="http://schemas.openxmlformats.org/officeDocument/2006/relationships" xmlns:p="http://schemas.openxmlformats.org/presentationml/2006/main">
   <p:cSld>
     <p:spTree>
       <p:nvGrpSpPr>
@@ -3826,7 +4018,14 @@
         <p:cNvGrpSpPr/>
         <p:nvPr/>
       </p:nvGrpSpPr>
-      <p:grpSpPr/>
+      <p:grpSpPr>
+        <a:xfrm>
+          <a:off x="0" y="0"/>
+          <a:ext cx="0" cy="0"/>
+          <a:chOff x="0" y="0"/>
+          <a:chExt cx="0" cy="0"/>
+        </a:xfrm>
+      </p:grpSpPr>
       <p:sp>
         <p:nvSpPr>
           <p:cNvPr id="2" name="Rectangle 1"/>
@@ -3867,6 +4066,7 @@
           <a:lstStyle/>
           <a:p>
             <a:pPr algn="ctr"/>
+            <a:endParaRPr/>
           </a:p>
         </p:txBody>
       </p:sp>
@@ -3975,11 +4175,17 @@
           <p:cNvGraphicFramePr>
             <a:graphicFrameLocks noGrp="1"/>
           </p:cNvGraphicFramePr>
-          <p:nvPr/>
+          <p:nvPr>
+            <p:extLst>
+              <p:ext uri="{D42A27DB-BD31-4B8C-83A1-F6EECF244321}">
+                <p14:modId xmlns:p14="http://schemas.microsoft.com/office/powerpoint/2010/main" val="3607273962"/>
+              </p:ext>
+            </p:extLst>
+          </p:nvPr>
         </p:nvGraphicFramePr>
         <p:xfrm>
-          <a:off x="548640" y="1697926"/>
-          <a:ext cx="5394960" cy="1188720"/>
+          <a:off x="548640" y="1824218"/>
+          <a:ext cx="5394960" cy="1624584"/>
         </p:xfrm>
         <a:graphic>
           <a:graphicData uri="http://schemas.openxmlformats.org/drawingml/2006/table">
@@ -3988,8 +4194,20 @@
                 <a:tableStyleId>{5C22544A-7EE6-4342-B048-85BDC9FD1C3A}</a:tableStyleId>
               </a:tblPr>
               <a:tblGrid>
-                <a:gridCol w="2697480"/>
-                <a:gridCol w="2697480"/>
+                <a:gridCol w="2697480">
+                  <a:extLst>
+                    <a:ext uri="{9D8B030D-6E8A-4147-A177-3AD203B41FA5}">
+                      <a16:colId xmlns:a16="http://schemas.microsoft.com/office/drawing/2014/main" val="20000"/>
+                    </a:ext>
+                  </a:extLst>
+                </a:gridCol>
+                <a:gridCol w="2697480">
+                  <a:extLst>
+                    <a:ext uri="{9D8B030D-6E8A-4147-A177-3AD203B41FA5}">
+                      <a16:colId xmlns:a16="http://schemas.microsoft.com/office/drawing/2014/main" val="20001"/>
+                    </a:ext>
+                  </a:extLst>
+                </a:gridCol>
               </a:tblGrid>
               <a:tr h="237744">
                 <a:tc>
@@ -4038,6 +4256,11 @@
                     </a:solidFill>
                   </a:tcPr>
                 </a:tc>
+                <a:extLst>
+                  <a:ext uri="{0D108BD9-81ED-4DB2-BD59-A6C34878D82A}">
+                    <a16:rowId xmlns:a16="http://schemas.microsoft.com/office/drawing/2014/main" val="10000"/>
+                  </a:ext>
+                </a:extLst>
               </a:tr>
               <a:tr h="237744">
                 <a:tc>
@@ -4086,6 +4309,11 @@
                     </a:solidFill>
                   </a:tcPr>
                 </a:tc>
+                <a:extLst>
+                  <a:ext uri="{0D108BD9-81ED-4DB2-BD59-A6C34878D82A}">
+                    <a16:rowId xmlns:a16="http://schemas.microsoft.com/office/drawing/2014/main" val="10001"/>
+                  </a:ext>
+                </a:extLst>
               </a:tr>
               <a:tr h="237744">
                 <a:tc>
@@ -4134,6 +4362,11 @@
                     </a:solidFill>
                   </a:tcPr>
                 </a:tc>
+                <a:extLst>
+                  <a:ext uri="{0D108BD9-81ED-4DB2-BD59-A6C34878D82A}">
+                    <a16:rowId xmlns:a16="http://schemas.microsoft.com/office/drawing/2014/main" val="10002"/>
+                  </a:ext>
+                </a:extLst>
               </a:tr>
               <a:tr h="237744">
                 <a:tc>
@@ -4182,6 +4415,11 @@
                     </a:solidFill>
                   </a:tcPr>
                 </a:tc>
+                <a:extLst>
+                  <a:ext uri="{0D108BD9-81ED-4DB2-BD59-A6C34878D82A}">
+                    <a16:rowId xmlns:a16="http://schemas.microsoft.com/office/drawing/2014/main" val="10003"/>
+                  </a:ext>
+                </a:extLst>
               </a:tr>
               <a:tr h="237744">
                 <a:tc>
@@ -4230,6 +4468,11 @@
                     </a:solidFill>
                   </a:tcPr>
                 </a:tc>
+                <a:extLst>
+                  <a:ext uri="{0D108BD9-81ED-4DB2-BD59-A6C34878D82A}">
+                    <a16:rowId xmlns:a16="http://schemas.microsoft.com/office/drawing/2014/main" val="10004"/>
+                  </a:ext>
+                </a:extLst>
               </a:tr>
             </a:tbl>
           </a:graphicData>
@@ -4243,7 +4486,7 @@
         </p:nvSpPr>
         <p:spPr>
           <a:xfrm>
-            <a:off x="548640" y="3014662"/>
+            <a:off x="548640" y="3471825"/>
             <a:ext cx="5394960" cy="274320"/>
           </a:xfrm>
           <a:prstGeom prst="rect">
@@ -4276,7 +4519,7 @@
         </p:nvSpPr>
         <p:spPr>
           <a:xfrm>
-            <a:off x="548640" y="3339845"/>
+            <a:off x="548640" y="4057651"/>
             <a:ext cx="5394960" cy="274320"/>
           </a:xfrm>
           <a:prstGeom prst="rect">
@@ -4307,11 +4550,17 @@
           <p:cNvGraphicFramePr>
             <a:graphicFrameLocks noGrp="1"/>
           </p:cNvGraphicFramePr>
-          <p:nvPr/>
+          <p:nvPr>
+            <p:extLst>
+              <p:ext uri="{D42A27DB-BD31-4B8C-83A1-F6EECF244321}">
+                <p14:modId xmlns:p14="http://schemas.microsoft.com/office/powerpoint/2010/main" val="820017221"/>
+              </p:ext>
+            </p:extLst>
+          </p:nvPr>
         </p:nvGraphicFramePr>
         <p:xfrm>
-          <a:off x="548640" y="3661028"/>
-          <a:ext cx="5394960" cy="950976"/>
+          <a:off x="548640" y="4481286"/>
+          <a:ext cx="5394960" cy="1100328"/>
         </p:xfrm>
         <a:graphic>
           <a:graphicData uri="http://schemas.openxmlformats.org/drawingml/2006/table">
@@ -4320,10 +4569,22 @@
                 <a:tableStyleId>{5C22544A-7EE6-4342-B048-85BDC9FD1C3A}</a:tableStyleId>
               </a:tblPr>
               <a:tblGrid>
-                <a:gridCol w="2697480"/>
-                <a:gridCol w="2697480"/>
+                <a:gridCol w="2697480">
+                  <a:extLst>
+                    <a:ext uri="{9D8B030D-6E8A-4147-A177-3AD203B41FA5}">
+                      <a16:colId xmlns:a16="http://schemas.microsoft.com/office/drawing/2014/main" val="20000"/>
+                    </a:ext>
+                  </a:extLst>
+                </a:gridCol>
+                <a:gridCol w="2697480">
+                  <a:extLst>
+                    <a:ext uri="{9D8B030D-6E8A-4147-A177-3AD203B41FA5}">
+                      <a16:colId xmlns:a16="http://schemas.microsoft.com/office/drawing/2014/main" val="20001"/>
+                    </a:ext>
+                  </a:extLst>
+                </a:gridCol>
               </a:tblGrid>
-              <a:tr h="237744">
+              <a:tr h="241172">
                 <a:tc>
                   <a:txBody>
                     <a:bodyPr/>
@@ -4370,6 +4631,11 @@
                     </a:solidFill>
                   </a:tcPr>
                 </a:tc>
+                <a:extLst>
+                  <a:ext uri="{0D108BD9-81ED-4DB2-BD59-A6C34878D82A}">
+                    <a16:rowId xmlns:a16="http://schemas.microsoft.com/office/drawing/2014/main" val="10000"/>
+                  </a:ext>
+                </a:extLst>
               </a:tr>
               <a:tr h="237744">
                 <a:tc>
@@ -4418,6 +4684,11 @@
                     </a:solidFill>
                   </a:tcPr>
                 </a:tc>
+                <a:extLst>
+                  <a:ext uri="{0D108BD9-81ED-4DB2-BD59-A6C34878D82A}">
+                    <a16:rowId xmlns:a16="http://schemas.microsoft.com/office/drawing/2014/main" val="10001"/>
+                  </a:ext>
+                </a:extLst>
               </a:tr>
               <a:tr h="237744">
                 <a:tc>
@@ -4466,6 +4737,11 @@
                     </a:solidFill>
                   </a:tcPr>
                 </a:tc>
+                <a:extLst>
+                  <a:ext uri="{0D108BD9-81ED-4DB2-BD59-A6C34878D82A}">
+                    <a16:rowId xmlns:a16="http://schemas.microsoft.com/office/drawing/2014/main" val="10002"/>
+                  </a:ext>
+                </a:extLst>
               </a:tr>
               <a:tr h="237744">
                 <a:tc>
@@ -4514,6 +4790,11 @@
                     </a:solidFill>
                   </a:tcPr>
                 </a:tc>
+                <a:extLst>
+                  <a:ext uri="{0D108BD9-81ED-4DB2-BD59-A6C34878D82A}">
+                    <a16:rowId xmlns:a16="http://schemas.microsoft.com/office/drawing/2014/main" val="10003"/>
+                  </a:ext>
+                </a:extLst>
               </a:tr>
             </a:tbl>
           </a:graphicData>
@@ -4527,7 +4808,7 @@
         </p:nvSpPr>
         <p:spPr>
           <a:xfrm>
-            <a:off x="548640" y="4794884"/>
+            <a:off x="6400800" y="1106424"/>
             <a:ext cx="5394960" cy="274320"/>
           </a:xfrm>
           <a:prstGeom prst="rect">
@@ -4568,7 +4849,7 @@
         </p:blipFill>
         <p:spPr>
           <a:xfrm>
-            <a:off x="6400800" y="1051560"/>
+            <a:off x="6400800" y="1497331"/>
             <a:ext cx="3847927" cy="2834640"/>
           </a:xfrm>
           <a:prstGeom prst="rect">
@@ -4584,7 +4865,7 @@
         </p:nvSpPr>
         <p:spPr>
           <a:xfrm>
-            <a:off x="6400800" y="4014216"/>
+            <a:off x="6400800" y="4448558"/>
             <a:ext cx="5394960" cy="274320"/>
           </a:xfrm>
           <a:prstGeom prst="rect">
@@ -4684,7 +4965,7 @@
 </file>
 
 <file path=ppt/slides/slide3.xml><?xml version="1.0" encoding="utf-8"?>
-<p:sld xmlns:a="http://schemas.openxmlformats.org/drawingml/2006/main" xmlns:p="http://schemas.openxmlformats.org/presentationml/2006/main" xmlns:r="http://schemas.openxmlformats.org/officeDocument/2006/relationships">
+<p:sld xmlns:a="http://schemas.openxmlformats.org/drawingml/2006/main" xmlns:r="http://schemas.openxmlformats.org/officeDocument/2006/relationships" xmlns:p="http://schemas.openxmlformats.org/presentationml/2006/main">
   <p:cSld>
     <p:spTree>
       <p:nvGrpSpPr>
@@ -4692,7 +4973,14 @@
         <p:cNvGrpSpPr/>
         <p:nvPr/>
       </p:nvGrpSpPr>
-      <p:grpSpPr/>
+      <p:grpSpPr>
+        <a:xfrm>
+          <a:off x="0" y="0"/>
+          <a:ext cx="0" cy="0"/>
+          <a:chOff x="0" y="0"/>
+          <a:chExt cx="0" cy="0"/>
+        </a:xfrm>
+      </p:grpSpPr>
       <p:sp>
         <p:nvSpPr>
           <p:cNvPr id="2" name="Rectangle 1"/>
@@ -4733,6 +5021,7 @@
           <a:lstStyle/>
           <a:p>
             <a:pPr algn="ctr"/>
+            <a:endParaRPr/>
           </a:p>
         </p:txBody>
       </p:sp>
@@ -4843,7 +5132,7 @@
         </p:nvSpPr>
         <p:spPr>
           <a:xfrm>
-            <a:off x="548640" y="1661350"/>
+            <a:off x="548640" y="1978669"/>
             <a:ext cx="5394960" cy="274320"/>
           </a:xfrm>
           <a:prstGeom prst="rect">
@@ -4884,7 +5173,7 @@
         </p:blipFill>
         <p:spPr>
           <a:xfrm>
-            <a:off x="548640" y="1931669"/>
+            <a:off x="548640" y="2447438"/>
             <a:ext cx="5394960" cy="2820092"/>
           </a:xfrm>
           <a:prstGeom prst="rect">
@@ -4900,7 +5189,7 @@
         </p:nvSpPr>
         <p:spPr>
           <a:xfrm>
-            <a:off x="548640" y="4879777"/>
+            <a:off x="548640" y="5461980"/>
             <a:ext cx="5394960" cy="274320"/>
           </a:xfrm>
           <a:prstGeom prst="rect">
@@ -4999,7 +5288,7 @@
         </p:nvSpPr>
         <p:spPr>
           <a:xfrm>
-            <a:off x="6400800" y="1661350"/>
+            <a:off x="6400800" y="2141860"/>
             <a:ext cx="5394960" cy="274320"/>
           </a:xfrm>
           <a:prstGeom prst="rect">
@@ -5030,11 +5319,17 @@
           <p:cNvGraphicFramePr>
             <a:graphicFrameLocks noGrp="1"/>
           </p:cNvGraphicFramePr>
-          <p:nvPr/>
+          <p:nvPr>
+            <p:extLst>
+              <p:ext uri="{D42A27DB-BD31-4B8C-83A1-F6EECF244321}">
+                <p14:modId xmlns:p14="http://schemas.microsoft.com/office/powerpoint/2010/main" val="3329160871"/>
+              </p:ext>
+            </p:extLst>
+          </p:nvPr>
         </p:nvGraphicFramePr>
         <p:xfrm>
-          <a:off x="6400800" y="1968245"/>
-          <a:ext cx="5394960" cy="713232"/>
+          <a:off x="6400800" y="2426467"/>
+          <a:ext cx="5394960" cy="862584"/>
         </p:xfrm>
         <a:graphic>
           <a:graphicData uri="http://schemas.openxmlformats.org/drawingml/2006/table">
@@ -5043,8 +5338,20 @@
                 <a:tableStyleId>{5C22544A-7EE6-4342-B048-85BDC9FD1C3A}</a:tableStyleId>
               </a:tblPr>
               <a:tblGrid>
-                <a:gridCol w="2697480"/>
-                <a:gridCol w="2697480"/>
+                <a:gridCol w="2697480">
+                  <a:extLst>
+                    <a:ext uri="{9D8B030D-6E8A-4147-A177-3AD203B41FA5}">
+                      <a16:colId xmlns:a16="http://schemas.microsoft.com/office/drawing/2014/main" val="20000"/>
+                    </a:ext>
+                  </a:extLst>
+                </a:gridCol>
+                <a:gridCol w="2697480">
+                  <a:extLst>
+                    <a:ext uri="{9D8B030D-6E8A-4147-A177-3AD203B41FA5}">
+                      <a16:colId xmlns:a16="http://schemas.microsoft.com/office/drawing/2014/main" val="20001"/>
+                    </a:ext>
+                  </a:extLst>
+                </a:gridCol>
               </a:tblGrid>
               <a:tr h="237744">
                 <a:tc>
@@ -5093,6 +5400,11 @@
                     </a:solidFill>
                   </a:tcPr>
                 </a:tc>
+                <a:extLst>
+                  <a:ext uri="{0D108BD9-81ED-4DB2-BD59-A6C34878D82A}">
+                    <a16:rowId xmlns:a16="http://schemas.microsoft.com/office/drawing/2014/main" val="10000"/>
+                  </a:ext>
+                </a:extLst>
               </a:tr>
               <a:tr h="237744">
                 <a:tc>
@@ -5141,6 +5453,11 @@
                     </a:solidFill>
                   </a:tcPr>
                 </a:tc>
+                <a:extLst>
+                  <a:ext uri="{0D108BD9-81ED-4DB2-BD59-A6C34878D82A}">
+                    <a16:rowId xmlns:a16="http://schemas.microsoft.com/office/drawing/2014/main" val="10001"/>
+                  </a:ext>
+                </a:extLst>
               </a:tr>
               <a:tr h="237744">
                 <a:tc>
@@ -5189,6 +5506,11 @@
                     </a:solidFill>
                   </a:tcPr>
                 </a:tc>
+                <a:extLst>
+                  <a:ext uri="{0D108BD9-81ED-4DB2-BD59-A6C34878D82A}">
+                    <a16:rowId xmlns:a16="http://schemas.microsoft.com/office/drawing/2014/main" val="10002"/>
+                  </a:ext>
+                </a:extLst>
               </a:tr>
             </a:tbl>
           </a:graphicData>
@@ -5202,7 +5524,7 @@
         </p:nvSpPr>
         <p:spPr>
           <a:xfrm>
-            <a:off x="6400800" y="2809493"/>
+            <a:off x="6400800" y="3361849"/>
             <a:ext cx="5394960" cy="274320"/>
           </a:xfrm>
           <a:prstGeom prst="rect">
@@ -5233,11 +5555,17 @@
           <p:cNvGraphicFramePr>
             <a:graphicFrameLocks noGrp="1"/>
           </p:cNvGraphicFramePr>
-          <p:nvPr/>
+          <p:nvPr>
+            <p:extLst>
+              <p:ext uri="{D42A27DB-BD31-4B8C-83A1-F6EECF244321}">
+                <p14:modId xmlns:p14="http://schemas.microsoft.com/office/powerpoint/2010/main" val="2296200322"/>
+              </p:ext>
+            </p:extLst>
+          </p:nvPr>
         </p:nvGraphicFramePr>
         <p:xfrm>
-          <a:off x="6400800" y="3116388"/>
-          <a:ext cx="5394960" cy="475488"/>
+          <a:off x="6400800" y="3709511"/>
+          <a:ext cx="5394960" cy="481584"/>
         </p:xfrm>
         <a:graphic>
           <a:graphicData uri="http://schemas.openxmlformats.org/drawingml/2006/table">
@@ -5246,9 +5574,27 @@
                 <a:tableStyleId>{5C22544A-7EE6-4342-B048-85BDC9FD1C3A}</a:tableStyleId>
               </a:tblPr>
               <a:tblGrid>
-                <a:gridCol w="1798320"/>
-                <a:gridCol w="1798320"/>
-                <a:gridCol w="1798320"/>
+                <a:gridCol w="1798320">
+                  <a:extLst>
+                    <a:ext uri="{9D8B030D-6E8A-4147-A177-3AD203B41FA5}">
+                      <a16:colId xmlns:a16="http://schemas.microsoft.com/office/drawing/2014/main" val="20000"/>
+                    </a:ext>
+                  </a:extLst>
+                </a:gridCol>
+                <a:gridCol w="1798320">
+                  <a:extLst>
+                    <a:ext uri="{9D8B030D-6E8A-4147-A177-3AD203B41FA5}">
+                      <a16:colId xmlns:a16="http://schemas.microsoft.com/office/drawing/2014/main" val="20001"/>
+                    </a:ext>
+                  </a:extLst>
+                </a:gridCol>
+                <a:gridCol w="1798320">
+                  <a:extLst>
+                    <a:ext uri="{9D8B030D-6E8A-4147-A177-3AD203B41FA5}">
+                      <a16:colId xmlns:a16="http://schemas.microsoft.com/office/drawing/2014/main" val="20002"/>
+                    </a:ext>
+                  </a:extLst>
+                </a:gridCol>
               </a:tblGrid>
               <a:tr h="237744">
                 <a:tc>
@@ -5320,6 +5666,11 @@
                     </a:solidFill>
                   </a:tcPr>
                 </a:tc>
+                <a:extLst>
+                  <a:ext uri="{0D108BD9-81ED-4DB2-BD59-A6C34878D82A}">
+                    <a16:rowId xmlns:a16="http://schemas.microsoft.com/office/drawing/2014/main" val="10000"/>
+                  </a:ext>
+                </a:extLst>
               </a:tr>
               <a:tr h="237744">
                 <a:tc>
@@ -5391,6 +5742,11 @@
                     </a:solidFill>
                   </a:tcPr>
                 </a:tc>
+                <a:extLst>
+                  <a:ext uri="{0D108BD9-81ED-4DB2-BD59-A6C34878D82A}">
+                    <a16:rowId xmlns:a16="http://schemas.microsoft.com/office/drawing/2014/main" val="10001"/>
+                  </a:ext>
+                </a:extLst>
               </a:tr>
             </a:tbl>
           </a:graphicData>
@@ -5471,7 +5827,7 @@
 </file>
 
 <file path=ppt/slides/slide4.xml><?xml version="1.0" encoding="utf-8"?>
-<p:sld xmlns:a="http://schemas.openxmlformats.org/drawingml/2006/main" xmlns:p="http://schemas.openxmlformats.org/presentationml/2006/main" xmlns:r="http://schemas.openxmlformats.org/officeDocument/2006/relationships">
+<p:sld xmlns:a="http://schemas.openxmlformats.org/drawingml/2006/main" xmlns:r="http://schemas.openxmlformats.org/officeDocument/2006/relationships" xmlns:p="http://schemas.openxmlformats.org/presentationml/2006/main">
   <p:cSld>
     <p:spTree>
       <p:nvGrpSpPr>
@@ -5479,7 +5835,14 @@
         <p:cNvGrpSpPr/>
         <p:nvPr/>
       </p:nvGrpSpPr>
-      <p:grpSpPr/>
+      <p:grpSpPr>
+        <a:xfrm>
+          <a:off x="0" y="0"/>
+          <a:ext cx="0" cy="0"/>
+          <a:chOff x="0" y="0"/>
+          <a:chExt cx="0" cy="0"/>
+        </a:xfrm>
+      </p:grpSpPr>
       <p:sp>
         <p:nvSpPr>
           <p:cNvPr id="2" name="Rectangle 1"/>
@@ -5520,6 +5883,7 @@
           <a:lstStyle/>
           <a:p>
             <a:pPr algn="ctr"/>
+            <a:endParaRPr/>
           </a:p>
         </p:txBody>
       </p:sp>
@@ -5630,7 +5994,7 @@
         </p:nvSpPr>
         <p:spPr>
           <a:xfrm>
-            <a:off x="548640" y="1661350"/>
+            <a:off x="548640" y="1880807"/>
             <a:ext cx="5394960" cy="274320"/>
           </a:xfrm>
           <a:prstGeom prst="rect">
@@ -5741,7 +6105,7 @@
         </p:nvSpPr>
         <p:spPr>
           <a:xfrm>
-            <a:off x="548640" y="2895790"/>
+            <a:off x="548640" y="3134678"/>
             <a:ext cx="5394960" cy="274320"/>
           </a:xfrm>
           <a:prstGeom prst="rect">
@@ -5774,7 +6138,7 @@
         </p:nvSpPr>
         <p:spPr>
           <a:xfrm>
-            <a:off x="548640" y="3220973"/>
+            <a:off x="548640" y="3807047"/>
             <a:ext cx="5394960" cy="274320"/>
           </a:xfrm>
           <a:prstGeom prst="rect">
@@ -5805,11 +6169,17 @@
           <p:cNvGraphicFramePr>
             <a:graphicFrameLocks noGrp="1"/>
           </p:cNvGraphicFramePr>
-          <p:nvPr/>
+          <p:nvPr>
+            <p:extLst>
+              <p:ext uri="{D42A27DB-BD31-4B8C-83A1-F6EECF244321}">
+                <p14:modId xmlns:p14="http://schemas.microsoft.com/office/powerpoint/2010/main" val="4101949488"/>
+              </p:ext>
+            </p:extLst>
+          </p:nvPr>
         </p:nvGraphicFramePr>
         <p:xfrm>
-          <a:off x="548640" y="3542156"/>
-          <a:ext cx="5394960" cy="1188720"/>
+          <a:off x="548640" y="4230243"/>
+          <a:ext cx="5394960" cy="1481328"/>
         </p:xfrm>
         <a:graphic>
           <a:graphicData uri="http://schemas.openxmlformats.org/drawingml/2006/table">
@@ -5818,9 +6188,27 @@
                 <a:tableStyleId>{5C22544A-7EE6-4342-B048-85BDC9FD1C3A}</a:tableStyleId>
               </a:tblPr>
               <a:tblGrid>
-                <a:gridCol w="1798320"/>
-                <a:gridCol w="1798320"/>
-                <a:gridCol w="1798320"/>
+                <a:gridCol w="1798320">
+                  <a:extLst>
+                    <a:ext uri="{9D8B030D-6E8A-4147-A177-3AD203B41FA5}">
+                      <a16:colId xmlns:a16="http://schemas.microsoft.com/office/drawing/2014/main" val="20000"/>
+                    </a:ext>
+                  </a:extLst>
+                </a:gridCol>
+                <a:gridCol w="1798320">
+                  <a:extLst>
+                    <a:ext uri="{9D8B030D-6E8A-4147-A177-3AD203B41FA5}">
+                      <a16:colId xmlns:a16="http://schemas.microsoft.com/office/drawing/2014/main" val="20001"/>
+                    </a:ext>
+                  </a:extLst>
+                </a:gridCol>
+                <a:gridCol w="1798320">
+                  <a:extLst>
+                    <a:ext uri="{9D8B030D-6E8A-4147-A177-3AD203B41FA5}">
+                      <a16:colId xmlns:a16="http://schemas.microsoft.com/office/drawing/2014/main" val="20002"/>
+                    </a:ext>
+                  </a:extLst>
+                </a:gridCol>
               </a:tblGrid>
               <a:tr h="237744">
                 <a:tc>
@@ -5892,6 +6280,11 @@
                     </a:solidFill>
                   </a:tcPr>
                 </a:tc>
+                <a:extLst>
+                  <a:ext uri="{0D108BD9-81ED-4DB2-BD59-A6C34878D82A}">
+                    <a16:rowId xmlns:a16="http://schemas.microsoft.com/office/drawing/2014/main" val="10000"/>
+                  </a:ext>
+                </a:extLst>
               </a:tr>
               <a:tr h="237744">
                 <a:tc>
@@ -5963,6 +6356,11 @@
                     </a:solidFill>
                   </a:tcPr>
                 </a:tc>
+                <a:extLst>
+                  <a:ext uri="{0D108BD9-81ED-4DB2-BD59-A6C34878D82A}">
+                    <a16:rowId xmlns:a16="http://schemas.microsoft.com/office/drawing/2014/main" val="10001"/>
+                  </a:ext>
+                </a:extLst>
               </a:tr>
               <a:tr h="237744">
                 <a:tc>
@@ -6034,6 +6432,11 @@
                     </a:solidFill>
                   </a:tcPr>
                 </a:tc>
+                <a:extLst>
+                  <a:ext uri="{0D108BD9-81ED-4DB2-BD59-A6C34878D82A}">
+                    <a16:rowId xmlns:a16="http://schemas.microsoft.com/office/drawing/2014/main" val="10002"/>
+                  </a:ext>
+                </a:extLst>
               </a:tr>
               <a:tr h="237744">
                 <a:tc>
@@ -6105,6 +6508,11 @@
                     </a:solidFill>
                   </a:tcPr>
                 </a:tc>
+                <a:extLst>
+                  <a:ext uri="{0D108BD9-81ED-4DB2-BD59-A6C34878D82A}">
+                    <a16:rowId xmlns:a16="http://schemas.microsoft.com/office/drawing/2014/main" val="10003"/>
+                  </a:ext>
+                </a:extLst>
               </a:tr>
               <a:tr h="237744">
                 <a:tc>
@@ -6176,6 +6584,11 @@
                     </a:solidFill>
                   </a:tcPr>
                 </a:tc>
+                <a:extLst>
+                  <a:ext uri="{0D108BD9-81ED-4DB2-BD59-A6C34878D82A}">
+                    <a16:rowId xmlns:a16="http://schemas.microsoft.com/office/drawing/2014/main" val="10004"/>
+                  </a:ext>
+                </a:extLst>
               </a:tr>
             </a:tbl>
           </a:graphicData>
@@ -6189,7 +6602,7 @@
         </p:nvSpPr>
         <p:spPr>
           <a:xfrm>
-            <a:off x="548640" y="4858892"/>
+            <a:off x="548640" y="5699570"/>
             <a:ext cx="5394960" cy="274320"/>
           </a:xfrm>
           <a:prstGeom prst="rect">
@@ -6288,7 +6701,7 @@
         </p:nvSpPr>
         <p:spPr>
           <a:xfrm>
-            <a:off x="6400800" y="1716214"/>
+            <a:off x="6400800" y="2205133"/>
             <a:ext cx="5394960" cy="274320"/>
           </a:xfrm>
           <a:prstGeom prst="rect">
@@ -6321,7 +6734,7 @@
         </p:nvSpPr>
         <p:spPr>
           <a:xfrm>
-            <a:off x="6400800" y="2000821"/>
+            <a:off x="6400800" y="2479453"/>
             <a:ext cx="5394960" cy="274320"/>
           </a:xfrm>
           <a:prstGeom prst="rect">
@@ -6421,7 +6834,7 @@
 </file>
 
 <file path=ppt/slides/slide5.xml><?xml version="1.0" encoding="utf-8"?>
-<p:sld xmlns:a="http://schemas.openxmlformats.org/drawingml/2006/main" xmlns:p="http://schemas.openxmlformats.org/presentationml/2006/main" xmlns:r="http://schemas.openxmlformats.org/officeDocument/2006/relationships">
+<p:sld xmlns:a="http://schemas.openxmlformats.org/drawingml/2006/main" xmlns:r="http://schemas.openxmlformats.org/officeDocument/2006/relationships" xmlns:p="http://schemas.openxmlformats.org/presentationml/2006/main">
   <p:cSld>
     <p:spTree>
       <p:nvGrpSpPr>
@@ -6429,7 +6842,14 @@
         <p:cNvGrpSpPr/>
         <p:nvPr/>
       </p:nvGrpSpPr>
-      <p:grpSpPr/>
+      <p:grpSpPr>
+        <a:xfrm>
+          <a:off x="0" y="0"/>
+          <a:ext cx="0" cy="0"/>
+          <a:chOff x="0" y="0"/>
+          <a:chExt cx="0" cy="0"/>
+        </a:xfrm>
+      </p:grpSpPr>
       <p:sp>
         <p:nvSpPr>
           <p:cNvPr id="2" name="Rectangle 1"/>
@@ -6470,6 +6890,7 @@
           <a:lstStyle/>
           <a:p>
             <a:pPr algn="ctr"/>
+            <a:endParaRPr/>
           </a:p>
         </p:txBody>
       </p:sp>
@@ -6580,7 +7001,7 @@
         </p:nvSpPr>
         <p:spPr>
           <a:xfrm>
-            <a:off x="548640" y="1661350"/>
+            <a:off x="548640" y="1948796"/>
             <a:ext cx="5394960" cy="274320"/>
           </a:xfrm>
           <a:prstGeom prst="rect">
@@ -6611,11 +7032,17 @@
           <p:cNvGraphicFramePr>
             <a:graphicFrameLocks noGrp="1"/>
           </p:cNvGraphicFramePr>
-          <p:nvPr/>
+          <p:nvPr>
+            <p:extLst>
+              <p:ext uri="{D42A27DB-BD31-4B8C-83A1-F6EECF244321}">
+                <p14:modId xmlns:p14="http://schemas.microsoft.com/office/powerpoint/2010/main" val="1391235262"/>
+              </p:ext>
+            </p:extLst>
+          </p:nvPr>
         </p:nvGraphicFramePr>
         <p:xfrm>
-          <a:off x="548640" y="1968245"/>
-          <a:ext cx="5394960" cy="713232"/>
+          <a:off x="548640" y="2219556"/>
+          <a:ext cx="5394960" cy="862584"/>
         </p:xfrm>
         <a:graphic>
           <a:graphicData uri="http://schemas.openxmlformats.org/drawingml/2006/table">
@@ -6624,8 +7051,20 @@
                 <a:tableStyleId>{5C22544A-7EE6-4342-B048-85BDC9FD1C3A}</a:tableStyleId>
               </a:tblPr>
               <a:tblGrid>
-                <a:gridCol w="2697480"/>
-                <a:gridCol w="2697480"/>
+                <a:gridCol w="2697480">
+                  <a:extLst>
+                    <a:ext uri="{9D8B030D-6E8A-4147-A177-3AD203B41FA5}">
+                      <a16:colId xmlns:a16="http://schemas.microsoft.com/office/drawing/2014/main" val="20000"/>
+                    </a:ext>
+                  </a:extLst>
+                </a:gridCol>
+                <a:gridCol w="2697480">
+                  <a:extLst>
+                    <a:ext uri="{9D8B030D-6E8A-4147-A177-3AD203B41FA5}">
+                      <a16:colId xmlns:a16="http://schemas.microsoft.com/office/drawing/2014/main" val="20001"/>
+                    </a:ext>
+                  </a:extLst>
+                </a:gridCol>
               </a:tblGrid>
               <a:tr h="237744">
                 <a:tc>
@@ -6674,6 +7113,11 @@
                     </a:solidFill>
                   </a:tcPr>
                 </a:tc>
+                <a:extLst>
+                  <a:ext uri="{0D108BD9-81ED-4DB2-BD59-A6C34878D82A}">
+                    <a16:rowId xmlns:a16="http://schemas.microsoft.com/office/drawing/2014/main" val="10000"/>
+                  </a:ext>
+                </a:extLst>
               </a:tr>
               <a:tr h="237744">
                 <a:tc>
@@ -6722,6 +7166,11 @@
                     </a:solidFill>
                   </a:tcPr>
                 </a:tc>
+                <a:extLst>
+                  <a:ext uri="{0D108BD9-81ED-4DB2-BD59-A6C34878D82A}">
+                    <a16:rowId xmlns:a16="http://schemas.microsoft.com/office/drawing/2014/main" val="10001"/>
+                  </a:ext>
+                </a:extLst>
               </a:tr>
               <a:tr h="237744">
                 <a:tc>
@@ -6770,6 +7219,11 @@
                     </a:solidFill>
                   </a:tcPr>
                 </a:tc>
+                <a:extLst>
+                  <a:ext uri="{0D108BD9-81ED-4DB2-BD59-A6C34878D82A}">
+                    <a16:rowId xmlns:a16="http://schemas.microsoft.com/office/drawing/2014/main" val="10002"/>
+                  </a:ext>
+                </a:extLst>
               </a:tr>
             </a:tbl>
           </a:graphicData>
@@ -6783,7 +7237,7 @@
         </p:nvSpPr>
         <p:spPr>
           <a:xfrm>
-            <a:off x="548640" y="2809493"/>
+            <a:off x="548640" y="3075239"/>
             <a:ext cx="5394960" cy="274320"/>
           </a:xfrm>
           <a:prstGeom prst="rect">
@@ -6816,7 +7270,7 @@
         </p:nvSpPr>
         <p:spPr>
           <a:xfrm>
-            <a:off x="548640" y="3134676"/>
+            <a:off x="548640" y="3644456"/>
             <a:ext cx="5394960" cy="274320"/>
           </a:xfrm>
           <a:prstGeom prst="rect">
@@ -6849,7 +7303,7 @@
         </p:nvSpPr>
         <p:spPr>
           <a:xfrm>
-            <a:off x="548640" y="3419283"/>
+            <a:off x="548640" y="3946661"/>
             <a:ext cx="5394960" cy="274320"/>
           </a:xfrm>
           <a:prstGeom prst="rect">
@@ -6882,7 +7336,7 @@
         </p:nvSpPr>
         <p:spPr>
           <a:xfrm>
-            <a:off x="548640" y="3689602"/>
+            <a:off x="548640" y="4399057"/>
             <a:ext cx="5394960" cy="274320"/>
           </a:xfrm>
           <a:prstGeom prst="rect">
@@ -6927,7 +7381,7 @@
         </p:nvSpPr>
         <p:spPr>
           <a:xfrm>
-            <a:off x="548640" y="4101082"/>
+            <a:off x="548640" y="4830281"/>
             <a:ext cx="5394960" cy="274320"/>
           </a:xfrm>
           <a:prstGeom prst="rect">
@@ -6960,7 +7414,7 @@
         </p:nvSpPr>
         <p:spPr>
           <a:xfrm>
-            <a:off x="548640" y="4426265"/>
+            <a:off x="6309360" y="1109283"/>
             <a:ext cx="5394960" cy="274320"/>
           </a:xfrm>
           <a:prstGeom prst="rect">
@@ -6991,11 +7445,17 @@
           <p:cNvGraphicFramePr>
             <a:graphicFrameLocks noGrp="1"/>
           </p:cNvGraphicFramePr>
-          <p:nvPr/>
+          <p:nvPr>
+            <p:extLst>
+              <p:ext uri="{D42A27DB-BD31-4B8C-83A1-F6EECF244321}">
+                <p14:modId xmlns:p14="http://schemas.microsoft.com/office/powerpoint/2010/main" val="3130294314"/>
+              </p:ext>
+            </p:extLst>
+          </p:nvPr>
         </p:nvGraphicFramePr>
         <p:xfrm>
-          <a:off x="548640" y="4747448"/>
-          <a:ext cx="5394960" cy="1188720"/>
+          <a:off x="6309360" y="1409893"/>
+          <a:ext cx="5394960" cy="1769364"/>
         </p:xfrm>
         <a:graphic>
           <a:graphicData uri="http://schemas.openxmlformats.org/drawingml/2006/table">
@@ -7004,11 +7464,29 @@
                 <a:tableStyleId>{5C22544A-7EE6-4342-B048-85BDC9FD1C3A}</a:tableStyleId>
               </a:tblPr>
               <a:tblGrid>
-                <a:gridCol w="1798320"/>
-                <a:gridCol w="1798320"/>
-                <a:gridCol w="1798320"/>
+                <a:gridCol w="1798320">
+                  <a:extLst>
+                    <a:ext uri="{9D8B030D-6E8A-4147-A177-3AD203B41FA5}">
+                      <a16:colId xmlns:a16="http://schemas.microsoft.com/office/drawing/2014/main" val="20000"/>
+                    </a:ext>
+                  </a:extLst>
+                </a:gridCol>
+                <a:gridCol w="1798320">
+                  <a:extLst>
+                    <a:ext uri="{9D8B030D-6E8A-4147-A177-3AD203B41FA5}">
+                      <a16:colId xmlns:a16="http://schemas.microsoft.com/office/drawing/2014/main" val="20001"/>
+                    </a:ext>
+                  </a:extLst>
+                </a:gridCol>
+                <a:gridCol w="1798320">
+                  <a:extLst>
+                    <a:ext uri="{9D8B030D-6E8A-4147-A177-3AD203B41FA5}">
+                      <a16:colId xmlns:a16="http://schemas.microsoft.com/office/drawing/2014/main" val="20002"/>
+                    </a:ext>
+                  </a:extLst>
+                </a:gridCol>
               </a:tblGrid>
-              <a:tr h="237744">
+              <a:tr h="227921">
                 <a:tc>
                   <a:txBody>
                     <a:bodyPr/>
@@ -7078,6 +7556,11 @@
                     </a:solidFill>
                   </a:tcPr>
                 </a:tc>
+                <a:extLst>
+                  <a:ext uri="{0D108BD9-81ED-4DB2-BD59-A6C34878D82A}">
+                    <a16:rowId xmlns:a16="http://schemas.microsoft.com/office/drawing/2014/main" val="10000"/>
+                  </a:ext>
+                </a:extLst>
               </a:tr>
               <a:tr h="237744">
                 <a:tc>
@@ -7149,6 +7632,11 @@
                     </a:solidFill>
                   </a:tcPr>
                 </a:tc>
+                <a:extLst>
+                  <a:ext uri="{0D108BD9-81ED-4DB2-BD59-A6C34878D82A}">
+                    <a16:rowId xmlns:a16="http://schemas.microsoft.com/office/drawing/2014/main" val="10001"/>
+                  </a:ext>
+                </a:extLst>
               </a:tr>
               <a:tr h="237744">
                 <a:tc>
@@ -7220,6 +7708,11 @@
                     </a:solidFill>
                   </a:tcPr>
                 </a:tc>
+                <a:extLst>
+                  <a:ext uri="{0D108BD9-81ED-4DB2-BD59-A6C34878D82A}">
+                    <a16:rowId xmlns:a16="http://schemas.microsoft.com/office/drawing/2014/main" val="10002"/>
+                  </a:ext>
+                </a:extLst>
               </a:tr>
               <a:tr h="237744">
                 <a:tc>
@@ -7291,6 +7784,11 @@
                     </a:solidFill>
                   </a:tcPr>
                 </a:tc>
+                <a:extLst>
+                  <a:ext uri="{0D108BD9-81ED-4DB2-BD59-A6C34878D82A}">
+                    <a16:rowId xmlns:a16="http://schemas.microsoft.com/office/drawing/2014/main" val="10003"/>
+                  </a:ext>
+                </a:extLst>
               </a:tr>
               <a:tr h="237744">
                 <a:tc>
@@ -7362,6 +7860,11 @@
                     </a:solidFill>
                   </a:tcPr>
                 </a:tc>
+                <a:extLst>
+                  <a:ext uri="{0D108BD9-81ED-4DB2-BD59-A6C34878D82A}">
+                    <a16:rowId xmlns:a16="http://schemas.microsoft.com/office/drawing/2014/main" val="10004"/>
+                  </a:ext>
+                </a:extLst>
               </a:tr>
             </a:tbl>
           </a:graphicData>
@@ -7375,7 +7878,7 @@
         </p:nvSpPr>
         <p:spPr>
           <a:xfrm>
-            <a:off x="6400800" y="1051560"/>
+            <a:off x="6309360" y="3220212"/>
             <a:ext cx="5394960" cy="274320"/>
           </a:xfrm>
           <a:prstGeom prst="rect">
@@ -7408,7 +7911,7 @@
         </p:nvSpPr>
         <p:spPr>
           <a:xfrm>
-            <a:off x="6400800" y="1376743"/>
+            <a:off x="6309360" y="3809501"/>
             <a:ext cx="5394960" cy="274320"/>
           </a:xfrm>
           <a:prstGeom prst="rect">
@@ -7441,7 +7944,7 @@
         </p:nvSpPr>
         <p:spPr>
           <a:xfrm>
-            <a:off x="6400800" y="1661350"/>
+            <a:off x="6309360" y="4101082"/>
             <a:ext cx="5394960" cy="274320"/>
           </a:xfrm>
           <a:prstGeom prst="rect">
@@ -7474,7 +7977,7 @@
         </p:nvSpPr>
         <p:spPr>
           <a:xfrm>
-            <a:off x="6400800" y="1931669"/>
+            <a:off x="6400800" y="6242492"/>
             <a:ext cx="5394960" cy="274320"/>
           </a:xfrm>
           <a:prstGeom prst="rect">

</xml_diff>